<commit_message>
refine limited / weak notion of generalization
</commit_message>
<xml_diff>
--- a/IoT_IDS_Presentation.pptx
+++ b/IoT_IDS_Presentation.pptx
@@ -14308,7 +14308,7 @@
             <a:tbl>
               <a:tblPr>
                 <a:noFill/>
-                <a:tableStyleId>{E5AC7DA2-D840-44B8-BE18-492B14356F4E}</a:tableStyleId>
+                <a:tableStyleId>{5CC55CD7-5896-421A-AF81-9E40704EDEDE}</a:tableStyleId>
               </a:tblPr>
               <a:tblGrid>
                 <a:gridCol w="1310000"/>
@@ -21751,7 +21751,7 @@
             <a:tbl>
               <a:tblPr>
                 <a:noFill/>
-                <a:tableStyleId>{E5AC7DA2-D840-44B8-BE18-492B14356F4E}</a:tableStyleId>
+                <a:tableStyleId>{5CC55CD7-5896-421A-AF81-9E40704EDEDE}</a:tableStyleId>
               </a:tblPr>
               <a:tblGrid>
                 <a:gridCol w="2797025"/>
@@ -25333,43 +25333,6 @@
                 <a:sym typeface="Calibri"/>
               </a:rPr>
               <a:t>✅  7 of 9 devices achieve perfect F1 = 1.000. A single global model generalises across all IoT device types — no per-device retraining needed.</a:t>
-            </a:r>
-            <a:endParaRPr b="0" i="0" sz="1000" u="none" cap="none" strike="noStrike">
-              <a:solidFill>
-                <a:srgbClr val="E2E8F0"/>
-              </a:solidFill>
-              <a:latin typeface="Calibri"/>
-              <a:ea typeface="Calibri"/>
-              <a:cs typeface="Calibri"/>
-              <a:sym typeface="Calibri"/>
-            </a:endParaRPr>
-          </a:p>
-          <a:p>
-            <a:pPr indent="0" lvl="0" marL="0" rtl="0" algn="l">
-              <a:spcBef>
-                <a:spcPts val="0"/>
-              </a:spcBef>
-              <a:spcAft>
-                <a:spcPts val="0"/>
-              </a:spcAft>
-              <a:buClr>
-                <a:schemeClr val="dk1"/>
-              </a:buClr>
-              <a:buSzPts val="1100"/>
-              <a:buFont typeface="Arial"/>
-              <a:buNone/>
-            </a:pPr>
-            <a:r>
-              <a:rPr lang="en-US" sz="1000">
-                <a:solidFill>
-                  <a:srgbClr val="B7B7B7"/>
-                </a:solidFill>
-                <a:latin typeface="Calibri"/>
-                <a:ea typeface="Calibri"/>
-                <a:cs typeface="Calibri"/>
-                <a:sym typeface="Calibri"/>
-              </a:rPr>
-              <a:t>Exploratory device-wise results are consistently strong within this benchmark sample, but this is not a leave-one-device-out generalization test.</a:t>
             </a:r>
             <a:endParaRPr sz="1000">
               <a:solidFill>

</xml_diff>